<commit_message>
docs: update pitch slides with schedule comparison for TGS
Co-authored-by: Cursor <cursoragent@cursor.com>
</commit_message>
<xml_diff>
--- a/docs/presentation-idolelic.pptx
+++ b/docs/presentation-idolelic.pptx
@@ -5450,7 +5450,7 @@
                 </a:solidFill>
                 <a:latin typeface="Yu Gothic UI"/>
               </a:rPr>
-              <a:t>・アプリ内ナビ／聖地登録</a:t>
+              <a:t>・ナビ・聖地登録・掲示板</a:t>
             </a:r>
           </a:p>
           <a:p>
@@ -5466,7 +5466,7 @@
                 </a:solidFill>
                 <a:latin typeface="Yu Gothic UI"/>
               </a:rPr>
-              <a:t>・Auth・公式65件・管理画面</a:t>
+              <a:t>・本番公開（Vercel）・Auth</a:t>
             </a:r>
           </a:p>
         </p:txBody>
@@ -5550,7 +5550,7 @@
                 </a:solidFill>
                 <a:latin typeface="Yu Gothic UI"/>
               </a:rPr>
-              <a:t>直前</a:t>
+              <a:t>いま</a:t>
             </a:r>
           </a:p>
         </p:txBody>
@@ -5589,7 +5589,7 @@
                 </a:solidFill>
                 <a:latin typeface="Yu Gothic UI"/>
               </a:rPr>
-              <a:t>・Vercel 本番デプロイ</a:t>
+              <a:t>・仲いい人に配布中</a:t>
             </a:r>
           </a:p>
           <a:p>
@@ -5605,7 +5605,7 @@
                 </a:solidFill>
                 <a:latin typeface="Yu Gothic UI"/>
               </a:rPr>
-              <a:t>・本番 URL の Auth 設定</a:t>
+              <a:t>・使ってもらい意見を獲得</a:t>
             </a:r>
           </a:p>
           <a:p>
@@ -5621,7 +5621,7 @@
                 </a:solidFill>
                 <a:latin typeface="Yu Gothic UI"/>
               </a:rPr>
-              <a:t>・通しスモークテスト</a:t>
+              <a:t>・改善ポイントの洗い出し</a:t>
             </a:r>
           </a:p>
         </p:txBody>
@@ -5705,7 +5705,7 @@
                 </a:solidFill>
                 <a:latin typeface="Yu Gothic UI"/>
               </a:rPr>
-              <a:t>夏休み</a:t>
+              <a:t>TGSまで</a:t>
             </a:r>
           </a:p>
         </p:txBody>
@@ -5744,7 +5744,7 @@
                 </a:solidFill>
                 <a:latin typeface="Yu Gothic UI"/>
               </a:rPr>
-              <a:t>・一般公開・運用開始</a:t>
+              <a:t>・意見をもとに改善</a:t>
             </a:r>
           </a:p>
           <a:p>
@@ -5760,7 +5760,7 @@
                 </a:solidFill>
                 <a:latin typeface="Yu Gothic UI"/>
               </a:rPr>
-              <a:t>・ユーザー獲得</a:t>
+              <a:t>・発表に向けて仕上げ</a:t>
             </a:r>
           </a:p>
           <a:p>
@@ -5776,7 +5776,7 @@
                 </a:solidFill>
                 <a:latin typeface="Yu Gothic UI"/>
               </a:rPr>
-              <a:t>・掲示板DBなど拡張</a:t>
+              <a:t>・TGSで発表</a:t>
             </a:r>
           </a:p>
         </p:txBody>
@@ -6140,21 +6140,99 @@
                 </a:solidFill>
                 <a:latin typeface="Yu Gothic UI"/>
               </a:rPr>
-              <a:t>MVPは実装完了目前。次は本番公開でトラクション獲得</a:t>
-            </a:r>
-          </a:p>
-        </p:txBody>
-      </p:sp>
-      <p:sp>
-        <p:nvSpPr>
-          <p:cNvPr id="4" name="Rounded Rectangle 3"/>
+              <a:t>スケジュール比較：以前の予定と、いまの進捗</a:t>
+            </a:r>
+          </a:p>
+        </p:txBody>
+      </p:sp>
+      <p:sp>
+        <p:nvSpPr>
+          <p:cNvPr id="4" name="TextBox 3"/>
+          <p:cNvSpPr txBox="1"/>
+          <p:nvPr/>
+        </p:nvSpPr>
+        <p:spPr>
+          <a:xfrm>
+            <a:off x="502920" y="1097280"/>
+            <a:ext cx="11155680" cy="320040"/>
+          </a:xfrm>
+          <a:prstGeom prst="rect">
+            <a:avLst/>
+          </a:prstGeom>
+          <a:noFill/>
+        </p:spPr>
+        <p:txBody>
+          <a:bodyPr wrap="square">
+            <a:spAutoFit/>
+          </a:bodyPr>
+          <a:lstStyle/>
+          <a:p>
+            <a:pPr algn="l">
+              <a:spcAft>
+                <a:spcPts val="0"/>
+              </a:spcAft>
+            </a:pPr>
+            <a:r>
+              <a:rPr sz="1100" b="0">
+                <a:solidFill>
+                  <a:srgbClr val="5C5C5C"/>
+                </a:solidFill>
+                <a:latin typeface="Yu Gothic UI"/>
+              </a:rPr>
+              <a:t>以前は本番公開のあと夏休みで一般公開予定。いまは本番まで完了し、知人配布で意見収集→TGS発表へ。</a:t>
+            </a:r>
+          </a:p>
+        </p:txBody>
+      </p:sp>
+      <p:sp>
+        <p:nvSpPr>
+          <p:cNvPr id="5" name="TextBox 4"/>
+          <p:cNvSpPr txBox="1"/>
+          <p:nvPr/>
+        </p:nvSpPr>
+        <p:spPr>
+          <a:xfrm>
+            <a:off x="502920" y="1463040"/>
+            <a:ext cx="10972800" cy="256032"/>
+          </a:xfrm>
+          <a:prstGeom prst="rect">
+            <a:avLst/>
+          </a:prstGeom>
+          <a:noFill/>
+        </p:spPr>
+        <p:txBody>
+          <a:bodyPr wrap="square">
+            <a:spAutoFit/>
+          </a:bodyPr>
+          <a:lstStyle/>
+          <a:p>
+            <a:pPr algn="l">
+              <a:spcAft>
+                <a:spcPts val="0"/>
+              </a:spcAft>
+            </a:pPr>
+            <a:r>
+              <a:rPr sz="1200" b="1">
+                <a:solidFill>
+                  <a:srgbClr val="5C5C5C"/>
+                </a:solidFill>
+                <a:latin typeface="Yu Gothic UI"/>
+              </a:rPr>
+              <a:t>以前の予定スケジュール</a:t>
+            </a:r>
+          </a:p>
+        </p:txBody>
+      </p:sp>
+      <p:sp>
+        <p:nvSpPr>
+          <p:cNvPr id="6" name="Rounded Rectangle 5"/>
           <p:cNvSpPr/>
           <p:nvPr/>
         </p:nvSpPr>
         <p:spPr>
           <a:xfrm>
-            <a:off x="411480" y="1554480"/>
-            <a:ext cx="2148840" cy="2926080"/>
+            <a:off x="411480" y="1783080"/>
+            <a:ext cx="2148840" cy="1691640"/>
           </a:xfrm>
           <a:prstGeom prst="roundRect">
             <a:avLst/>
@@ -6192,13 +6270,13 @@
       </p:sp>
       <p:sp>
         <p:nvSpPr>
-          <p:cNvPr id="5" name="TextBox 4"/>
+          <p:cNvPr id="7" name="TextBox 6"/>
           <p:cNvSpPr txBox="1"/>
           <p:nvPr/>
         </p:nvSpPr>
         <p:spPr>
           <a:xfrm>
-            <a:off x="548640" y="1664208"/>
+            <a:off x="548640" y="1892808"/>
             <a:ext cx="1874520" cy="320040"/>
           </a:xfrm>
           <a:prstGeom prst="rect">
@@ -6231,14 +6309,14 @@
       </p:sp>
       <p:sp>
         <p:nvSpPr>
-          <p:cNvPr id="6" name="TextBox 5"/>
+          <p:cNvPr id="8" name="TextBox 7"/>
           <p:cNvSpPr txBox="1"/>
           <p:nvPr/>
         </p:nvSpPr>
         <p:spPr>
           <a:xfrm>
-            <a:off x="548640" y="1965960"/>
-            <a:ext cx="1874520" cy="2423160"/>
+            <a:off x="548640" y="2194560"/>
+            <a:ext cx="1874520" cy="1188720"/>
           </a:xfrm>
           <a:prstGeom prst="rect">
             <a:avLst/>
@@ -6263,21 +6341,21 @@
                 </a:solidFill>
                 <a:latin typeface="Yu Gothic UI"/>
               </a:rPr>
-              <a:t>コア歩数計＆マップの基本実装完了</a:t>
-            </a:r>
-          </a:p>
-        </p:txBody>
-      </p:sp>
-      <p:sp>
-        <p:nvSpPr>
-          <p:cNvPr id="7" name="Rounded Rectangle 6"/>
+              <a:t>コア歩数計＆マップ実装</a:t>
+            </a:r>
+          </a:p>
+        </p:txBody>
+      </p:sp>
+      <p:sp>
+        <p:nvSpPr>
+          <p:cNvPr id="9" name="Rounded Rectangle 8"/>
           <p:cNvSpPr/>
           <p:nvPr/>
         </p:nvSpPr>
         <p:spPr>
           <a:xfrm>
-            <a:off x="2697480" y="1554480"/>
-            <a:ext cx="2148840" cy="2926080"/>
+            <a:off x="2697480" y="1783080"/>
+            <a:ext cx="2148840" cy="1691640"/>
           </a:xfrm>
           <a:prstGeom prst="roundRect">
             <a:avLst/>
@@ -6315,13 +6393,13 @@
       </p:sp>
       <p:sp>
         <p:nvSpPr>
-          <p:cNvPr id="8" name="TextBox 7"/>
+          <p:cNvPr id="10" name="TextBox 9"/>
           <p:cNvSpPr txBox="1"/>
           <p:nvPr/>
         </p:nvSpPr>
         <p:spPr>
           <a:xfrm>
-            <a:off x="2834640" y="1664208"/>
+            <a:off x="2834640" y="1892808"/>
             <a:ext cx="1874520" cy="320040"/>
           </a:xfrm>
           <a:prstGeom prst="rect">
@@ -6354,14 +6432,14 @@
       </p:sp>
       <p:sp>
         <p:nvSpPr>
-          <p:cNvPr id="9" name="TextBox 8"/>
+          <p:cNvPr id="11" name="TextBox 10"/>
           <p:cNvSpPr txBox="1"/>
           <p:nvPr/>
         </p:nvSpPr>
         <p:spPr>
           <a:xfrm>
-            <a:off x="2834640" y="1965960"/>
-            <a:ext cx="1874520" cy="2423160"/>
+            <a:off x="2834640" y="2194560"/>
+            <a:ext cx="1874520" cy="1188720"/>
           </a:xfrm>
           <a:prstGeom prst="rect">
             <a:avLst/>
@@ -6386,21 +6464,21 @@
                 </a:solidFill>
                 <a:latin typeface="Yu Gothic UI"/>
               </a:rPr>
-              <a:t>HTTPSでGPS/歩数ログ確認</a:t>
-            </a:r>
-          </a:p>
-        </p:txBody>
-      </p:sp>
-      <p:sp>
-        <p:nvSpPr>
-          <p:cNvPr id="10" name="Rounded Rectangle 9"/>
+              <a:t>HTTPSでGPS/歩数確認</a:t>
+            </a:r>
+          </a:p>
+        </p:txBody>
+      </p:sp>
+      <p:sp>
+        <p:nvSpPr>
+          <p:cNvPr id="12" name="Rounded Rectangle 11"/>
           <p:cNvSpPr/>
           <p:nvPr/>
         </p:nvSpPr>
         <p:spPr>
           <a:xfrm>
-            <a:off x="4983480" y="1554480"/>
-            <a:ext cx="2148840" cy="2926080"/>
+            <a:off x="4983480" y="1783080"/>
+            <a:ext cx="2148840" cy="1691640"/>
           </a:xfrm>
           <a:prstGeom prst="roundRect">
             <a:avLst/>
@@ -6438,13 +6516,13 @@
       </p:sp>
       <p:sp>
         <p:nvSpPr>
-          <p:cNvPr id="11" name="TextBox 10"/>
+          <p:cNvPr id="13" name="TextBox 12"/>
           <p:cNvSpPr txBox="1"/>
           <p:nvPr/>
         </p:nvSpPr>
         <p:spPr>
           <a:xfrm>
-            <a:off x="5120640" y="1664208"/>
+            <a:off x="5120640" y="1892808"/>
             <a:ext cx="1874520" cy="320040"/>
           </a:xfrm>
           <a:prstGeom prst="rect">
@@ -6477,14 +6555,14 @@
       </p:sp>
       <p:sp>
         <p:nvSpPr>
-          <p:cNvPr id="12" name="TextBox 11"/>
+          <p:cNvPr id="14" name="TextBox 13"/>
           <p:cNvSpPr txBox="1"/>
           <p:nvPr/>
         </p:nvSpPr>
         <p:spPr>
           <a:xfrm>
-            <a:off x="5120640" y="1965960"/>
-            <a:ext cx="1874520" cy="2423160"/>
+            <a:off x="5120640" y="2194560"/>
+            <a:ext cx="1874520" cy="1188720"/>
           </a:xfrm>
           <a:prstGeom prst="rect">
             <a:avLst/>
@@ -6509,21 +6587,21 @@
                 </a:solidFill>
                 <a:latin typeface="Yu Gothic UI"/>
               </a:rPr>
-              <a:t>聖地65件・MV・ナビ・Auth・管理</a:t>
-            </a:r>
-          </a:p>
-        </p:txBody>
-      </p:sp>
-      <p:sp>
-        <p:nvSpPr>
-          <p:cNvPr id="13" name="Rounded Rectangle 12"/>
+              <a:t>聖地・MV・ナビ・Auth</a:t>
+            </a:r>
+          </a:p>
+        </p:txBody>
+      </p:sp>
+      <p:sp>
+        <p:nvSpPr>
+          <p:cNvPr id="15" name="Rounded Rectangle 14"/>
           <p:cNvSpPr/>
           <p:nvPr/>
         </p:nvSpPr>
         <p:spPr>
           <a:xfrm>
-            <a:off x="7269480" y="1554480"/>
-            <a:ext cx="2148840" cy="2926080"/>
+            <a:off x="7269480" y="1783080"/>
+            <a:ext cx="2148840" cy="1691640"/>
           </a:xfrm>
           <a:prstGeom prst="roundRect">
             <a:avLst/>
@@ -6561,13 +6639,13 @@
       </p:sp>
       <p:sp>
         <p:nvSpPr>
-          <p:cNvPr id="14" name="TextBox 13"/>
+          <p:cNvPr id="16" name="TextBox 15"/>
           <p:cNvSpPr txBox="1"/>
           <p:nvPr/>
         </p:nvSpPr>
         <p:spPr>
           <a:xfrm>
-            <a:off x="7406640" y="1664208"/>
+            <a:off x="7406640" y="1892808"/>
             <a:ext cx="1874520" cy="320040"/>
           </a:xfrm>
           <a:prstGeom prst="rect">
@@ -6589,7 +6667,7 @@
             <a:r>
               <a:rPr sz="1300" b="1">
                 <a:solidFill>
-                  <a:srgbClr val="E83E8C"/>
+                  <a:srgbClr val="5C5C5C"/>
                 </a:solidFill>
                 <a:latin typeface="Yu Gothic UI"/>
               </a:rPr>
@@ -6600,14 +6678,14 @@
       </p:sp>
       <p:sp>
         <p:nvSpPr>
-          <p:cNvPr id="15" name="TextBox 14"/>
+          <p:cNvPr id="17" name="TextBox 16"/>
           <p:cNvSpPr txBox="1"/>
           <p:nvPr/>
         </p:nvSpPr>
         <p:spPr>
           <a:xfrm>
-            <a:off x="7406640" y="1965960"/>
-            <a:ext cx="1874520" cy="2423160"/>
+            <a:off x="7406640" y="2194560"/>
+            <a:ext cx="1874520" cy="1188720"/>
           </a:xfrm>
           <a:prstGeom prst="rect">
             <a:avLst/>
@@ -6632,21 +6710,21 @@
                 </a:solidFill>
                 <a:latin typeface="Yu Gothic UI"/>
               </a:rPr>
-              <a:t>Vercelデプロイと通し確認</a:t>
-            </a:r>
-          </a:p>
-        </p:txBody>
-      </p:sp>
-      <p:sp>
-        <p:nvSpPr>
-          <p:cNvPr id="16" name="Rounded Rectangle 15"/>
+              <a:t>Vercelと通し確認</a:t>
+            </a:r>
+          </a:p>
+        </p:txBody>
+      </p:sp>
+      <p:sp>
+        <p:nvSpPr>
+          <p:cNvPr id="18" name="Rounded Rectangle 17"/>
           <p:cNvSpPr/>
           <p:nvPr/>
         </p:nvSpPr>
         <p:spPr>
           <a:xfrm>
-            <a:off x="9555480" y="1554480"/>
-            <a:ext cx="2148840" cy="2926080"/>
+            <a:off x="9555480" y="1783080"/>
+            <a:ext cx="2148840" cy="1691640"/>
           </a:xfrm>
           <a:prstGeom prst="roundRect">
             <a:avLst/>
@@ -6684,13 +6762,13 @@
       </p:sp>
       <p:sp>
         <p:nvSpPr>
-          <p:cNvPr id="17" name="TextBox 16"/>
+          <p:cNvPr id="19" name="TextBox 18"/>
           <p:cNvSpPr txBox="1"/>
           <p:nvPr/>
         </p:nvSpPr>
         <p:spPr>
           <a:xfrm>
-            <a:off x="9692640" y="1664208"/>
+            <a:off x="9692640" y="1892808"/>
             <a:ext cx="1874520" cy="320040"/>
           </a:xfrm>
           <a:prstGeom prst="rect">
@@ -6712,7 +6790,7 @@
             <a:r>
               <a:rPr sz="1300" b="1">
                 <a:solidFill>
-                  <a:srgbClr val="E83E8C"/>
+                  <a:srgbClr val="5C5C5C"/>
                 </a:solidFill>
                 <a:latin typeface="Yu Gothic UI"/>
               </a:rPr>
@@ -6723,14 +6801,14 @@
       </p:sp>
       <p:sp>
         <p:nvSpPr>
-          <p:cNvPr id="18" name="TextBox 17"/>
+          <p:cNvPr id="20" name="TextBox 19"/>
           <p:cNvSpPr txBox="1"/>
           <p:nvPr/>
         </p:nvSpPr>
         <p:spPr>
           <a:xfrm>
-            <a:off x="9692640" y="1965960"/>
-            <a:ext cx="1874520" cy="2423160"/>
+            <a:off x="9692640" y="2194560"/>
+            <a:ext cx="1874520" cy="1188720"/>
           </a:xfrm>
           <a:prstGeom prst="rect">
             <a:avLst/>
@@ -6755,20 +6833,797 @@
                 </a:solidFill>
                 <a:latin typeface="Yu Gothic UI"/>
               </a:rPr>
-              <a:t>トラクション獲得・掲示板DB等</a:t>
-            </a:r>
-          </a:p>
-        </p:txBody>
-      </p:sp>
-      <p:sp>
-        <p:nvSpPr>
-          <p:cNvPr id="19" name="Rounded Rectangle 18"/>
+              <a:t>一般公開・獲得・掲示板</a:t>
+            </a:r>
+          </a:p>
+        </p:txBody>
+      </p:sp>
+      <p:sp>
+        <p:nvSpPr>
+          <p:cNvPr id="21" name="TextBox 20"/>
+          <p:cNvSpPr txBox="1"/>
+          <p:nvPr/>
+        </p:nvSpPr>
+        <p:spPr>
+          <a:xfrm>
+            <a:off x="502920" y="3703320"/>
+            <a:ext cx="10972800" cy="256032"/>
+          </a:xfrm>
+          <a:prstGeom prst="rect">
+            <a:avLst/>
+          </a:prstGeom>
+          <a:noFill/>
+        </p:spPr>
+        <p:txBody>
+          <a:bodyPr wrap="square">
+            <a:spAutoFit/>
+          </a:bodyPr>
+          <a:lstStyle/>
+          <a:p>
+            <a:pPr algn="l">
+              <a:spcAft>
+                <a:spcPts val="0"/>
+              </a:spcAft>
+            </a:pPr>
+            <a:r>
+              <a:rPr sz="1200" b="1">
+                <a:solidFill>
+                  <a:srgbClr val="E83E8C"/>
+                </a:solidFill>
+                <a:latin typeface="Yu Gothic UI"/>
+              </a:rPr>
+              <a:t>いまの進捗スケジュール</a:t>
+            </a:r>
+          </a:p>
+        </p:txBody>
+      </p:sp>
+      <p:sp>
+        <p:nvSpPr>
+          <p:cNvPr id="22" name="Rounded Rectangle 21"/>
           <p:cNvSpPr/>
           <p:nvPr/>
         </p:nvSpPr>
         <p:spPr>
           <a:xfrm>
-            <a:off x="502920" y="4937760"/>
+            <a:off x="320040" y="4023360"/>
+            <a:ext cx="1828800" cy="1600200"/>
+          </a:xfrm>
+          <a:prstGeom prst="roundRect">
+            <a:avLst/>
+          </a:prstGeom>
+          <a:solidFill>
+            <a:srgbClr val="F7F7F8"/>
+          </a:solidFill>
+          <a:ln>
+            <a:solidFill>
+              <a:srgbClr val="EEEEEE"/>
+            </a:solidFill>
+          </a:ln>
+        </p:spPr>
+        <p:style>
+          <a:lnRef idx="1">
+            <a:schemeClr val="accent1"/>
+          </a:lnRef>
+          <a:fillRef idx="3">
+            <a:schemeClr val="accent1"/>
+          </a:fillRef>
+          <a:effectRef idx="2">
+            <a:schemeClr val="accent1"/>
+          </a:effectRef>
+          <a:fontRef idx="minor">
+            <a:schemeClr val="lt1"/>
+          </a:fontRef>
+        </p:style>
+        <p:txBody>
+          <a:bodyPr rtlCol="0" anchor="ctr"/>
+          <a:lstStyle/>
+          <a:p>
+            <a:pPr algn="ctr"/>
+          </a:p>
+        </p:txBody>
+      </p:sp>
+      <p:sp>
+        <p:nvSpPr>
+          <p:cNvPr id="23" name="TextBox 22"/>
+          <p:cNvSpPr txBox="1"/>
+          <p:nvPr/>
+        </p:nvSpPr>
+        <p:spPr>
+          <a:xfrm>
+            <a:off x="457200" y="4133088"/>
+            <a:ext cx="1554480" cy="320040"/>
+          </a:xfrm>
+          <a:prstGeom prst="rect">
+            <a:avLst/>
+          </a:prstGeom>
+          <a:noFill/>
+        </p:spPr>
+        <p:txBody>
+          <a:bodyPr wrap="square">
+            <a:spAutoFit/>
+          </a:bodyPr>
+          <a:lstStyle/>
+          <a:p>
+            <a:pPr algn="l">
+              <a:spcAft>
+                <a:spcPts val="0"/>
+              </a:spcAft>
+            </a:pPr>
+            <a:r>
+              <a:rPr sz="1300" b="1">
+                <a:solidFill>
+                  <a:srgbClr val="1F9D6A"/>
+                </a:solidFill>
+                <a:latin typeface="Yu Gothic UI"/>
+              </a:rPr>
+              <a:t>1. 機能追加</a:t>
+            </a:r>
+          </a:p>
+        </p:txBody>
+      </p:sp>
+      <p:sp>
+        <p:nvSpPr>
+          <p:cNvPr id="24" name="TextBox 23"/>
+          <p:cNvSpPr txBox="1"/>
+          <p:nvPr/>
+        </p:nvSpPr>
+        <p:spPr>
+          <a:xfrm>
+            <a:off x="457200" y="4434840"/>
+            <a:ext cx="1554480" cy="1097280"/>
+          </a:xfrm>
+          <a:prstGeom prst="rect">
+            <a:avLst/>
+          </a:prstGeom>
+          <a:noFill/>
+        </p:spPr>
+        <p:txBody>
+          <a:bodyPr wrap="square">
+            <a:spAutoFit/>
+          </a:bodyPr>
+          <a:lstStyle/>
+          <a:p>
+            <a:pPr algn="l">
+              <a:spcAft>
+                <a:spcPts val="400"/>
+              </a:spcAft>
+            </a:pPr>
+            <a:r>
+              <a:rPr sz="1100" b="0">
+                <a:solidFill>
+                  <a:srgbClr val="1A1A1A"/>
+                </a:solidFill>
+                <a:latin typeface="Yu Gothic UI"/>
+              </a:rPr>
+              <a:t>基本実装完了</a:t>
+            </a:r>
+          </a:p>
+        </p:txBody>
+      </p:sp>
+      <p:sp>
+        <p:nvSpPr>
+          <p:cNvPr id="25" name="Rounded Rectangle 24"/>
+          <p:cNvSpPr/>
+          <p:nvPr/>
+        </p:nvSpPr>
+        <p:spPr>
+          <a:xfrm>
+            <a:off x="2286000" y="4023360"/>
+            <a:ext cx="1828800" cy="1600200"/>
+          </a:xfrm>
+          <a:prstGeom prst="roundRect">
+            <a:avLst/>
+          </a:prstGeom>
+          <a:solidFill>
+            <a:srgbClr val="F7F7F8"/>
+          </a:solidFill>
+          <a:ln>
+            <a:solidFill>
+              <a:srgbClr val="EEEEEE"/>
+            </a:solidFill>
+          </a:ln>
+        </p:spPr>
+        <p:style>
+          <a:lnRef idx="1">
+            <a:schemeClr val="accent1"/>
+          </a:lnRef>
+          <a:fillRef idx="3">
+            <a:schemeClr val="accent1"/>
+          </a:fillRef>
+          <a:effectRef idx="2">
+            <a:schemeClr val="accent1"/>
+          </a:effectRef>
+          <a:fontRef idx="minor">
+            <a:schemeClr val="lt1"/>
+          </a:fontRef>
+        </p:style>
+        <p:txBody>
+          <a:bodyPr rtlCol="0" anchor="ctr"/>
+          <a:lstStyle/>
+          <a:p>
+            <a:pPr algn="ctr"/>
+          </a:p>
+        </p:txBody>
+      </p:sp>
+      <p:sp>
+        <p:nvSpPr>
+          <p:cNvPr id="26" name="TextBox 25"/>
+          <p:cNvSpPr txBox="1"/>
+          <p:nvPr/>
+        </p:nvSpPr>
+        <p:spPr>
+          <a:xfrm>
+            <a:off x="2423160" y="4133088"/>
+            <a:ext cx="1554480" cy="320040"/>
+          </a:xfrm>
+          <a:prstGeom prst="rect">
+            <a:avLst/>
+          </a:prstGeom>
+          <a:noFill/>
+        </p:spPr>
+        <p:txBody>
+          <a:bodyPr wrap="square">
+            <a:spAutoFit/>
+          </a:bodyPr>
+          <a:lstStyle/>
+          <a:p>
+            <a:pPr algn="l">
+              <a:spcAft>
+                <a:spcPts val="0"/>
+              </a:spcAft>
+            </a:pPr>
+            <a:r>
+              <a:rPr sz="1300" b="1">
+                <a:solidFill>
+                  <a:srgbClr val="1F9D6A"/>
+                </a:solidFill>
+                <a:latin typeface="Yu Gothic UI"/>
+              </a:rPr>
+              <a:t>2. 実機検証</a:t>
+            </a:r>
+          </a:p>
+        </p:txBody>
+      </p:sp>
+      <p:sp>
+        <p:nvSpPr>
+          <p:cNvPr id="27" name="TextBox 26"/>
+          <p:cNvSpPr txBox="1"/>
+          <p:nvPr/>
+        </p:nvSpPr>
+        <p:spPr>
+          <a:xfrm>
+            <a:off x="2423160" y="4434840"/>
+            <a:ext cx="1554480" cy="1097280"/>
+          </a:xfrm>
+          <a:prstGeom prst="rect">
+            <a:avLst/>
+          </a:prstGeom>
+          <a:noFill/>
+        </p:spPr>
+        <p:txBody>
+          <a:bodyPr wrap="square">
+            <a:spAutoFit/>
+          </a:bodyPr>
+          <a:lstStyle/>
+          <a:p>
+            <a:pPr algn="l">
+              <a:spcAft>
+                <a:spcPts val="400"/>
+              </a:spcAft>
+            </a:pPr>
+            <a:r>
+              <a:rPr sz="1100" b="0">
+                <a:solidFill>
+                  <a:srgbClr val="1A1A1A"/>
+                </a:solidFill>
+                <a:latin typeface="Yu Gothic UI"/>
+              </a:rPr>
+              <a:t>GPS/歩数確認済</a:t>
+            </a:r>
+          </a:p>
+        </p:txBody>
+      </p:sp>
+      <p:sp>
+        <p:nvSpPr>
+          <p:cNvPr id="28" name="Rounded Rectangle 27"/>
+          <p:cNvSpPr/>
+          <p:nvPr/>
+        </p:nvSpPr>
+        <p:spPr>
+          <a:xfrm>
+            <a:off x="4251960" y="4023360"/>
+            <a:ext cx="1828800" cy="1600200"/>
+          </a:xfrm>
+          <a:prstGeom prst="roundRect">
+            <a:avLst/>
+          </a:prstGeom>
+          <a:solidFill>
+            <a:srgbClr val="F7F7F8"/>
+          </a:solidFill>
+          <a:ln>
+            <a:solidFill>
+              <a:srgbClr val="EEEEEE"/>
+            </a:solidFill>
+          </a:ln>
+        </p:spPr>
+        <p:style>
+          <a:lnRef idx="1">
+            <a:schemeClr val="accent1"/>
+          </a:lnRef>
+          <a:fillRef idx="3">
+            <a:schemeClr val="accent1"/>
+          </a:fillRef>
+          <a:effectRef idx="2">
+            <a:schemeClr val="accent1"/>
+          </a:effectRef>
+          <a:fontRef idx="minor">
+            <a:schemeClr val="lt1"/>
+          </a:fontRef>
+        </p:style>
+        <p:txBody>
+          <a:bodyPr rtlCol="0" anchor="ctr"/>
+          <a:lstStyle/>
+          <a:p>
+            <a:pPr algn="ctr"/>
+          </a:p>
+        </p:txBody>
+      </p:sp>
+      <p:sp>
+        <p:nvSpPr>
+          <p:cNvPr id="29" name="TextBox 28"/>
+          <p:cNvSpPr txBox="1"/>
+          <p:nvPr/>
+        </p:nvSpPr>
+        <p:spPr>
+          <a:xfrm>
+            <a:off x="4389120" y="4133088"/>
+            <a:ext cx="1554480" cy="320040"/>
+          </a:xfrm>
+          <a:prstGeom prst="rect">
+            <a:avLst/>
+          </a:prstGeom>
+          <a:noFill/>
+        </p:spPr>
+        <p:txBody>
+          <a:bodyPr wrap="square">
+            <a:spAutoFit/>
+          </a:bodyPr>
+          <a:lstStyle/>
+          <a:p>
+            <a:pPr algn="l">
+              <a:spcAft>
+                <a:spcPts val="0"/>
+              </a:spcAft>
+            </a:pPr>
+            <a:r>
+              <a:rPr sz="1300" b="1">
+                <a:solidFill>
+                  <a:srgbClr val="1F9D6A"/>
+                </a:solidFill>
+                <a:latin typeface="Yu Gothic UI"/>
+              </a:rPr>
+              <a:t>3. MVP実装</a:t>
+            </a:r>
+          </a:p>
+        </p:txBody>
+      </p:sp>
+      <p:sp>
+        <p:nvSpPr>
+          <p:cNvPr id="30" name="TextBox 29"/>
+          <p:cNvSpPr txBox="1"/>
+          <p:nvPr/>
+        </p:nvSpPr>
+        <p:spPr>
+          <a:xfrm>
+            <a:off x="4389120" y="4434840"/>
+            <a:ext cx="1554480" cy="1097280"/>
+          </a:xfrm>
+          <a:prstGeom prst="rect">
+            <a:avLst/>
+          </a:prstGeom>
+          <a:noFill/>
+        </p:spPr>
+        <p:txBody>
+          <a:bodyPr wrap="square">
+            <a:spAutoFit/>
+          </a:bodyPr>
+          <a:lstStyle/>
+          <a:p>
+            <a:pPr algn="l">
+              <a:spcAft>
+                <a:spcPts val="400"/>
+              </a:spcAft>
+            </a:pPr>
+            <a:r>
+              <a:rPr sz="1100" b="0">
+                <a:solidFill>
+                  <a:srgbClr val="1A1A1A"/>
+                </a:solidFill>
+                <a:latin typeface="Yu Gothic UI"/>
+              </a:rPr>
+              <a:t>掲示板まで完了</a:t>
+            </a:r>
+          </a:p>
+        </p:txBody>
+      </p:sp>
+      <p:sp>
+        <p:nvSpPr>
+          <p:cNvPr id="31" name="Rounded Rectangle 30"/>
+          <p:cNvSpPr/>
+          <p:nvPr/>
+        </p:nvSpPr>
+        <p:spPr>
+          <a:xfrm>
+            <a:off x="6217920" y="4023360"/>
+            <a:ext cx="1828800" cy="1600200"/>
+          </a:xfrm>
+          <a:prstGeom prst="roundRect">
+            <a:avLst/>
+          </a:prstGeom>
+          <a:solidFill>
+            <a:srgbClr val="F7F7F8"/>
+          </a:solidFill>
+          <a:ln>
+            <a:solidFill>
+              <a:srgbClr val="EEEEEE"/>
+            </a:solidFill>
+          </a:ln>
+        </p:spPr>
+        <p:style>
+          <a:lnRef idx="1">
+            <a:schemeClr val="accent1"/>
+          </a:lnRef>
+          <a:fillRef idx="3">
+            <a:schemeClr val="accent1"/>
+          </a:fillRef>
+          <a:effectRef idx="2">
+            <a:schemeClr val="accent1"/>
+          </a:effectRef>
+          <a:fontRef idx="minor">
+            <a:schemeClr val="lt1"/>
+          </a:fontRef>
+        </p:style>
+        <p:txBody>
+          <a:bodyPr rtlCol="0" anchor="ctr"/>
+          <a:lstStyle/>
+          <a:p>
+            <a:pPr algn="ctr"/>
+          </a:p>
+        </p:txBody>
+      </p:sp>
+      <p:sp>
+        <p:nvSpPr>
+          <p:cNvPr id="32" name="TextBox 31"/>
+          <p:cNvSpPr txBox="1"/>
+          <p:nvPr/>
+        </p:nvSpPr>
+        <p:spPr>
+          <a:xfrm>
+            <a:off x="6355080" y="4133088"/>
+            <a:ext cx="1554480" cy="320040"/>
+          </a:xfrm>
+          <a:prstGeom prst="rect">
+            <a:avLst/>
+          </a:prstGeom>
+          <a:noFill/>
+        </p:spPr>
+        <p:txBody>
+          <a:bodyPr wrap="square">
+            <a:spAutoFit/>
+          </a:bodyPr>
+          <a:lstStyle/>
+          <a:p>
+            <a:pPr algn="l">
+              <a:spcAft>
+                <a:spcPts val="0"/>
+              </a:spcAft>
+            </a:pPr>
+            <a:r>
+              <a:rPr sz="1300" b="1">
+                <a:solidFill>
+                  <a:srgbClr val="1F9D6A"/>
+                </a:solidFill>
+                <a:latin typeface="Yu Gothic UI"/>
+              </a:rPr>
+              <a:t>4. 本番公開</a:t>
+            </a:r>
+          </a:p>
+        </p:txBody>
+      </p:sp>
+      <p:sp>
+        <p:nvSpPr>
+          <p:cNvPr id="33" name="TextBox 32"/>
+          <p:cNvSpPr txBox="1"/>
+          <p:nvPr/>
+        </p:nvSpPr>
+        <p:spPr>
+          <a:xfrm>
+            <a:off x="6355080" y="4434840"/>
+            <a:ext cx="1554480" cy="1097280"/>
+          </a:xfrm>
+          <a:prstGeom prst="rect">
+            <a:avLst/>
+          </a:prstGeom>
+          <a:noFill/>
+        </p:spPr>
+        <p:txBody>
+          <a:bodyPr wrap="square">
+            <a:spAutoFit/>
+          </a:bodyPr>
+          <a:lstStyle/>
+          <a:p>
+            <a:pPr algn="l">
+              <a:spcAft>
+                <a:spcPts val="400"/>
+              </a:spcAft>
+            </a:pPr>
+            <a:r>
+              <a:rPr sz="1100" b="0">
+                <a:solidFill>
+                  <a:srgbClr val="1A1A1A"/>
+                </a:solidFill>
+                <a:latin typeface="Yu Gothic UI"/>
+              </a:rPr>
+              <a:t>Vercel公開済</a:t>
+            </a:r>
+          </a:p>
+        </p:txBody>
+      </p:sp>
+      <p:sp>
+        <p:nvSpPr>
+          <p:cNvPr id="34" name="Rounded Rectangle 33"/>
+          <p:cNvSpPr/>
+          <p:nvPr/>
+        </p:nvSpPr>
+        <p:spPr>
+          <a:xfrm>
+            <a:off x="8183880" y="4023360"/>
+            <a:ext cx="1828800" cy="1600200"/>
+          </a:xfrm>
+          <a:prstGeom prst="roundRect">
+            <a:avLst/>
+          </a:prstGeom>
+          <a:solidFill>
+            <a:srgbClr val="F7F7F8"/>
+          </a:solidFill>
+          <a:ln>
+            <a:solidFill>
+              <a:srgbClr val="EEEEEE"/>
+            </a:solidFill>
+          </a:ln>
+        </p:spPr>
+        <p:style>
+          <a:lnRef idx="1">
+            <a:schemeClr val="accent1"/>
+          </a:lnRef>
+          <a:fillRef idx="3">
+            <a:schemeClr val="accent1"/>
+          </a:fillRef>
+          <a:effectRef idx="2">
+            <a:schemeClr val="accent1"/>
+          </a:effectRef>
+          <a:fontRef idx="minor">
+            <a:schemeClr val="lt1"/>
+          </a:fontRef>
+        </p:style>
+        <p:txBody>
+          <a:bodyPr rtlCol="0" anchor="ctr"/>
+          <a:lstStyle/>
+          <a:p>
+            <a:pPr algn="ctr"/>
+          </a:p>
+        </p:txBody>
+      </p:sp>
+      <p:sp>
+        <p:nvSpPr>
+          <p:cNvPr id="35" name="TextBox 34"/>
+          <p:cNvSpPr txBox="1"/>
+          <p:nvPr/>
+        </p:nvSpPr>
+        <p:spPr>
+          <a:xfrm>
+            <a:off x="8321040" y="4133088"/>
+            <a:ext cx="1554480" cy="320040"/>
+          </a:xfrm>
+          <a:prstGeom prst="rect">
+            <a:avLst/>
+          </a:prstGeom>
+          <a:noFill/>
+        </p:spPr>
+        <p:txBody>
+          <a:bodyPr wrap="square">
+            <a:spAutoFit/>
+          </a:bodyPr>
+          <a:lstStyle/>
+          <a:p>
+            <a:pPr algn="l">
+              <a:spcAft>
+                <a:spcPts val="0"/>
+              </a:spcAft>
+            </a:pPr>
+            <a:r>
+              <a:rPr sz="1300" b="1">
+                <a:solidFill>
+                  <a:srgbClr val="E83E8C"/>
+                </a:solidFill>
+                <a:latin typeface="Yu Gothic UI"/>
+              </a:rPr>
+              <a:t>5. 意見収集</a:t>
+            </a:r>
+          </a:p>
+        </p:txBody>
+      </p:sp>
+      <p:sp>
+        <p:nvSpPr>
+          <p:cNvPr id="36" name="TextBox 35"/>
+          <p:cNvSpPr txBox="1"/>
+          <p:nvPr/>
+        </p:nvSpPr>
+        <p:spPr>
+          <a:xfrm>
+            <a:off x="8321040" y="4434840"/>
+            <a:ext cx="1554480" cy="1097280"/>
+          </a:xfrm>
+          <a:prstGeom prst="rect">
+            <a:avLst/>
+          </a:prstGeom>
+          <a:noFill/>
+        </p:spPr>
+        <p:txBody>
+          <a:bodyPr wrap="square">
+            <a:spAutoFit/>
+          </a:bodyPr>
+          <a:lstStyle/>
+          <a:p>
+            <a:pPr algn="l">
+              <a:spcAft>
+                <a:spcPts val="400"/>
+              </a:spcAft>
+            </a:pPr>
+            <a:r>
+              <a:rPr sz="1100" b="0">
+                <a:solidFill>
+                  <a:srgbClr val="1A1A1A"/>
+                </a:solidFill>
+                <a:latin typeface="Yu Gothic UI"/>
+              </a:rPr>
+              <a:t>知人配布中</a:t>
+            </a:r>
+          </a:p>
+        </p:txBody>
+      </p:sp>
+      <p:sp>
+        <p:nvSpPr>
+          <p:cNvPr id="37" name="Rounded Rectangle 36"/>
+          <p:cNvSpPr/>
+          <p:nvPr/>
+        </p:nvSpPr>
+        <p:spPr>
+          <a:xfrm>
+            <a:off x="10149840" y="4023360"/>
+            <a:ext cx="1828800" cy="1600200"/>
+          </a:xfrm>
+          <a:prstGeom prst="roundRect">
+            <a:avLst/>
+          </a:prstGeom>
+          <a:solidFill>
+            <a:srgbClr val="F7F7F8"/>
+          </a:solidFill>
+          <a:ln>
+            <a:solidFill>
+              <a:srgbClr val="EEEEEE"/>
+            </a:solidFill>
+          </a:ln>
+        </p:spPr>
+        <p:style>
+          <a:lnRef idx="1">
+            <a:schemeClr val="accent1"/>
+          </a:lnRef>
+          <a:fillRef idx="3">
+            <a:schemeClr val="accent1"/>
+          </a:fillRef>
+          <a:effectRef idx="2">
+            <a:schemeClr val="accent1"/>
+          </a:effectRef>
+          <a:fontRef idx="minor">
+            <a:schemeClr val="lt1"/>
+          </a:fontRef>
+        </p:style>
+        <p:txBody>
+          <a:bodyPr rtlCol="0" anchor="ctr"/>
+          <a:lstStyle/>
+          <a:p>
+            <a:pPr algn="ctr"/>
+          </a:p>
+        </p:txBody>
+      </p:sp>
+      <p:sp>
+        <p:nvSpPr>
+          <p:cNvPr id="38" name="TextBox 37"/>
+          <p:cNvSpPr txBox="1"/>
+          <p:nvPr/>
+        </p:nvSpPr>
+        <p:spPr>
+          <a:xfrm>
+            <a:off x="10287000" y="4133088"/>
+            <a:ext cx="1554480" cy="320040"/>
+          </a:xfrm>
+          <a:prstGeom prst="rect">
+            <a:avLst/>
+          </a:prstGeom>
+          <a:noFill/>
+        </p:spPr>
+        <p:txBody>
+          <a:bodyPr wrap="square">
+            <a:spAutoFit/>
+          </a:bodyPr>
+          <a:lstStyle/>
+          <a:p>
+            <a:pPr algn="l">
+              <a:spcAft>
+                <a:spcPts val="0"/>
+              </a:spcAft>
+            </a:pPr>
+            <a:r>
+              <a:rPr sz="1300" b="1">
+                <a:solidFill>
+                  <a:srgbClr val="5C5C5C"/>
+                </a:solidFill>
+                <a:latin typeface="Yu Gothic UI"/>
+              </a:rPr>
+              <a:t>6. TGS発表</a:t>
+            </a:r>
+          </a:p>
+        </p:txBody>
+      </p:sp>
+      <p:sp>
+        <p:nvSpPr>
+          <p:cNvPr id="39" name="TextBox 38"/>
+          <p:cNvSpPr txBox="1"/>
+          <p:nvPr/>
+        </p:nvSpPr>
+        <p:spPr>
+          <a:xfrm>
+            <a:off x="10287000" y="4434840"/>
+            <a:ext cx="1554480" cy="1097280"/>
+          </a:xfrm>
+          <a:prstGeom prst="rect">
+            <a:avLst/>
+          </a:prstGeom>
+          <a:noFill/>
+        </p:spPr>
+        <p:txBody>
+          <a:bodyPr wrap="square">
+            <a:spAutoFit/>
+          </a:bodyPr>
+          <a:lstStyle/>
+          <a:p>
+            <a:pPr algn="l">
+              <a:spcAft>
+                <a:spcPts val="400"/>
+              </a:spcAft>
+            </a:pPr>
+            <a:r>
+              <a:rPr sz="1100" b="0">
+                <a:solidFill>
+                  <a:srgbClr val="1A1A1A"/>
+                </a:solidFill>
+                <a:latin typeface="Yu Gothic UI"/>
+              </a:rPr>
+              <a:t>改善して発表</a:t>
+            </a:r>
+          </a:p>
+        </p:txBody>
+      </p:sp>
+      <p:sp>
+        <p:nvSpPr>
+          <p:cNvPr id="40" name="Rounded Rectangle 39"/>
+          <p:cNvSpPr/>
+          <p:nvPr/>
+        </p:nvSpPr>
+        <p:spPr>
+          <a:xfrm>
+            <a:off x="502920" y="5806440"/>
             <a:ext cx="2212848" cy="310896"/>
           </a:xfrm>
           <a:prstGeom prst="roundRect">
@@ -6807,21 +7662,21 @@
                 </a:solidFill>
                 <a:latin typeface="Yu Gothic UI"/>
               </a:rPr>
-              <a:t>コア〜MVP機能 完了</a:t>
-            </a:r>
-          </a:p>
-        </p:txBody>
-      </p:sp>
-      <p:sp>
-        <p:nvSpPr>
-          <p:cNvPr id="20" name="Rounded Rectangle 19"/>
+              <a:t>本番公開まで前倒し完了</a:t>
+            </a:r>
+          </a:p>
+        </p:txBody>
+      </p:sp>
+      <p:sp>
+        <p:nvSpPr>
+          <p:cNvPr id="41" name="Rounded Rectangle 40"/>
           <p:cNvSpPr/>
           <p:nvPr/>
         </p:nvSpPr>
         <p:spPr>
           <a:xfrm>
-            <a:off x="2825496" y="4937760"/>
-            <a:ext cx="2414016" cy="310896"/>
+            <a:off x="2825496" y="5806440"/>
+            <a:ext cx="2615184" cy="310896"/>
           </a:xfrm>
           <a:prstGeom prst="roundRect">
             <a:avLst/>
@@ -6859,21 +7714,21 @@
                 </a:solidFill>
                 <a:latin typeface="Yu Gothic UI"/>
               </a:rPr>
-              <a:t>いま: Vercel公開</a:t>
-            </a:r>
-          </a:p>
-        </p:txBody>
-      </p:sp>
-      <p:sp>
-        <p:nvSpPr>
-          <p:cNvPr id="21" name="Rounded Rectangle 20"/>
+              <a:t>いま: 知人配布で意見獲得</a:t>
+            </a:r>
+          </a:p>
+        </p:txBody>
+      </p:sp>
+      <p:sp>
+        <p:nvSpPr>
+          <p:cNvPr id="42" name="Rounded Rectangle 41"/>
           <p:cNvSpPr/>
           <p:nvPr/>
         </p:nvSpPr>
         <p:spPr>
           <a:xfrm>
-            <a:off x="5349240" y="4937760"/>
-            <a:ext cx="2615184" cy="310896"/>
+            <a:off x="5550408" y="5806440"/>
+            <a:ext cx="3017520" cy="310896"/>
           </a:xfrm>
           <a:prstGeom prst="roundRect">
             <a:avLst/>
@@ -6911,53 +7766,14 @@
                 </a:solidFill>
                 <a:latin typeface="Yu Gothic UI"/>
               </a:rPr>
-              <a:t>夏休み: トラクション獲得</a:t>
-            </a:r>
-          </a:p>
-        </p:txBody>
-      </p:sp>
-      <p:sp>
-        <p:nvSpPr>
-          <p:cNvPr id="22" name="TextBox 21"/>
-          <p:cNvSpPr txBox="1"/>
-          <p:nvPr/>
-        </p:nvSpPr>
-        <p:spPr>
-          <a:xfrm>
-            <a:off x="502920" y="5669280"/>
-            <a:ext cx="10972800" cy="365760"/>
-          </a:xfrm>
-          <a:prstGeom prst="rect">
-            <a:avLst/>
-          </a:prstGeom>
-          <a:noFill/>
-        </p:spPr>
-        <p:txBody>
-          <a:bodyPr wrap="square">
-            <a:spAutoFit/>
-          </a:bodyPr>
-          <a:lstStyle/>
-          <a:p>
-            <a:pPr algn="l">
-              <a:spcAft>
-                <a:spcPts val="0"/>
-              </a:spcAft>
-            </a:pPr>
-            <a:r>
-              <a:rPr sz="1400" b="1">
-                <a:solidFill>
-                  <a:srgbClr val="C2185B"/>
-                </a:solidFill>
-                <a:latin typeface="Yu Gothic UI"/>
-              </a:rPr>
-              <a:t>デモURL: https://idolelic.vercel.app/home</a:t>
-            </a:r>
-          </a:p>
-        </p:txBody>
-      </p:sp>
-      <p:sp>
-        <p:nvSpPr>
-          <p:cNvPr id="23" name="TextBox 22"/>
+              <a:t>次: TGSまでに改善して発表</a:t>
+            </a:r>
+          </a:p>
+        </p:txBody>
+      </p:sp>
+      <p:sp>
+        <p:nvSpPr>
+          <p:cNvPr id="43" name="TextBox 42"/>
           <p:cNvSpPr txBox="1"/>
           <p:nvPr/>
         </p:nvSpPr>

</xml_diff>